<commit_message>
Add real service icons to slide 4 architecture diagram
- Add vscode.png, power-bi.png, fabric-lakehouse.png, fabric-notebook.png icons
- Update generate_deck_assets.ps1 to composite real icons into each architecture box (GitHub, VS Code + Copilot, Fabric notebook, Lakehouse, Power BI) instead of plain colored shapes
- Regenerate fabric-architecture.png and re-embed into the deck

Co-authored-by: Copilot <223556219+Copilot@users.noreply.github.com>
</commit_message>
<xml_diff>
--- a/deck/github-copilot-for-data-professionals.pptx
+++ b/deck/github-copilot-for-data-professionals.pptx
@@ -5,22 +5,22 @@
     <p:sldMasterId id="2147483650" r:id="rId1"/>
   </p:sldMasterIdLst>
   <p:notesMasterIdLst>
-    <p:notesMasterId r:id="rId25"/>
+    <p:notesMasterId r:id="rId15"/>
   </p:notesMasterIdLst>
   <p:sldIdLst>
-    <p:sldId id="256" r:id="rId12"/>
-    <p:sldId id="257" r:id="rId13"/>
-    <p:sldId id="258" r:id="rId14"/>
-    <p:sldId id="259" r:id="rId15"/>
-    <p:sldId id="260" r:id="rId16"/>
-    <p:sldId id="261" r:id="rId17"/>
-    <p:sldId id="262" r:id="rId18"/>
-    <p:sldId id="263" r:id="rId19"/>
-    <p:sldId id="264" r:id="rId20"/>
-    <p:sldId id="265" r:id="rId21"/>
-    <p:sldId id="266" r:id="rId22"/>
-    <p:sldId id="269" r:id="rId23"/>
-    <p:sldId id="270" r:id="rId24"/>
+    <p:sldId id="256" r:id="rId2"/>
+    <p:sldId id="257" r:id="rId3"/>
+    <p:sldId id="258" r:id="rId4"/>
+    <p:sldId id="259" r:id="rId5"/>
+    <p:sldId id="260" r:id="rId6"/>
+    <p:sldId id="261" r:id="rId7"/>
+    <p:sldId id="262" r:id="rId8"/>
+    <p:sldId id="263" r:id="rId9"/>
+    <p:sldId id="264" r:id="rId10"/>
+    <p:sldId id="265" r:id="rId11"/>
+    <p:sldId id="266" r:id="rId12"/>
+    <p:sldId id="269" r:id="rId13"/>
+    <p:sldId id="270" r:id="rId14"/>
   </p:sldIdLst>
   <p:sldSz cx="12436475" cy="6950075"/>
   <p:notesSz cx="6950075" cy="12436475"/>
@@ -1383,7 +1383,7 @@
 </p:notes>
 </file>
 
-<file path=ppt/slideLayouts/slideLayout33.xml><?xml version="1.0" encoding="utf-8"?>
+<file path=ppt/slideLayouts/slideLayout1.xml><?xml version="1.0" encoding="utf-8"?>
 <p:sldLayout xmlns:a="http://schemas.openxmlformats.org/drawingml/2006/main" xmlns:r="http://schemas.openxmlformats.org/officeDocument/2006/relationships" xmlns:p="http://schemas.openxmlformats.org/presentationml/2006/main">
   <p:cSld name="DEFAULT">
     <p:bg>
@@ -1542,7 +1542,7 @@
           <p:nvPr/>
         </p:nvPicPr>
         <p:blipFill>
-          <a:blip r:embed="rId35" cstate="screen">
+          <a:blip r:embed="rId3" cstate="screen">
             <a:extLst>
               <a:ext uri="{28A0092B-C50C-407E-A947-70E740481C1C}">
                 <a14:useLocalDpi xmlns:a14="http://schemas.microsoft.com/office/drawing/2010/main"/>
@@ -1572,7 +1572,7 @@
   </p:cSld>
   <p:clrMap bg1="lt1" tx1="dk1" bg2="lt2" tx2="dk2" accent1="accent1" accent2="accent2" accent3="accent3" accent4="accent4" accent5="accent5" accent6="accent6" hlink="hlink" folHlink="folHlink"/>
   <p:sldLayoutIdLst>
-    <p:sldLayoutId id="2147483683" r:id="rId33"/>
+    <p:sldLayoutId id="2147483683" r:id="rId1"/>
   </p:sldLayoutIdLst>
   <p:transition>
     <p:fade/>
@@ -5482,7 +5482,7 @@
                 <a:ea typeface="Segoe UI Semibold" pitchFamily="34" charset="-122"/>
                 <a:cs typeface="Segoe UI Semibold" pitchFamily="34" charset="-120"/>
               </a:rPr>
-              <a:t>Why Copilot lands for data teams</a:t>
+              <a:t>Why Copilot for data teams</a:t>
             </a:r>
             <a:endParaRPr lang="en-US" sz="3500" dirty="0"/>
           </a:p>
@@ -5496,7 +5496,7 @@
         </p:nvSpPr>
         <p:spPr>
           <a:xfrm>
-            <a:off x="10222992" y="320040"/>
+            <a:off x="11109960" y="338328"/>
             <a:ext cx="338328" cy="338328"/>
           </a:xfrm>
           <a:prstGeom prst="roundRect">
@@ -5540,7 +5540,7 @@
         </p:blipFill>
         <p:spPr>
           <a:xfrm>
-            <a:off x="10241280" y="338328"/>
+            <a:off x="11128248" y="356616"/>
             <a:ext cx="301752" cy="301752"/>
           </a:xfrm>
           <a:prstGeom prst="rect">
@@ -5556,7 +5556,7 @@
         </p:nvSpPr>
         <p:spPr>
           <a:xfrm>
-            <a:off x="10616184" y="320040"/>
+            <a:off x="11503152" y="338328"/>
             <a:ext cx="338328" cy="338328"/>
           </a:xfrm>
           <a:prstGeom prst="roundRect">
@@ -5600,7 +5600,7 @@
         </p:blipFill>
         <p:spPr>
           <a:xfrm>
-            <a:off x="10634472" y="338328"/>
+            <a:off x="11521440" y="356616"/>
             <a:ext cx="301752" cy="301752"/>
           </a:xfrm>
           <a:prstGeom prst="rect">
@@ -6184,8 +6184,8 @@
         </p:nvSpPr>
         <p:spPr>
           <a:xfrm>
-            <a:off x="658368" y="3401568"/>
-            <a:ext cx="11155680" cy="2011680"/>
+            <a:off x="658368" y="3859403"/>
+            <a:ext cx="11155680" cy="1398398"/>
           </a:xfrm>
           <a:prstGeom prst="roundRect">
             <a:avLst>
@@ -6207,44 +6207,6 @@
           <a:lstStyle/>
           <a:p>
             <a:endParaRPr lang="en-US"/>
-          </a:p>
-        </p:txBody>
-      </p:sp>
-      <p:sp>
-        <p:nvSpPr>
-          <p:cNvPr id="24" name="Text 20"/>
-          <p:cNvSpPr/>
-          <p:nvPr/>
-        </p:nvSpPr>
-        <p:spPr>
-          <a:xfrm>
-            <a:off x="914400" y="3657600"/>
-            <a:ext cx="3200400" cy="320040"/>
-          </a:xfrm>
-          <a:prstGeom prst="rect">
-            <a:avLst/>
-          </a:prstGeom>
-          <a:noFill/>
-          <a:ln/>
-        </p:spPr>
-        <p:txBody>
-          <a:bodyPr wrap="square" lIns="0" tIns="12700" rIns="0" bIns="12700" rtlCol="0" anchor="ctr">
-            <a:normAutofit/>
-          </a:bodyPr>
-          <a:lstStyle/>
-          <a:p>
-            <a:pPr marL="0" indent="0">
-              <a:buNone/>
-            </a:pPr>
-            <a:r>
-              <a:rPr lang="en-US" sz="1600" b="1" dirty="0">
-                <a:solidFill>
-                  <a:srgbClr val="000041"/>
-                </a:solidFill>
-              </a:rPr>
-              <a:t>Core message for the audience</a:t>
-            </a:r>
-            <a:endParaRPr lang="en-US" sz="1600" dirty="0"/>
           </a:p>
         </p:txBody>
       </p:sp>
@@ -12072,7 +12034,7 @@
 </a:theme>
 </file>
 
-<file path=ppt/theme/theme12.xml><?xml version="1.0" encoding="utf-8"?>
+<file path=ppt/theme/theme2.xml><?xml version="1.0" encoding="utf-8"?>
 <a:theme xmlns:a="http://schemas.openxmlformats.org/drawingml/2006/main" name="Office Theme">
   <a:themeElements>
     <a:clrScheme name="Office">

</xml_diff>

<commit_message>
Use official Fabric Lakehouse/Notebook icons, remove synthetic data mentions
- Replace generic Fluent icons for Fabric notebook and Lakehouse boxes with
  the official Microsoft Fabric item icons (from @fabric-msft/svg-icons)
- Regenerate architecture diagram and step 1 data-generator image
- Remove Synthetic data caption/wording from architecture diagram, step 1
  image, and slide 5 live-example caption (implied by demo context)

Co-authored-by: Copilot <223556219+Copilot@users.noreply.github.com>
</commit_message>
<xml_diff>
--- a/deck/github-copilot-for-data-professionals.pptx
+++ b/deck/github-copilot-for-data-professionals.pptx
@@ -600,93 +600,6 @@
 </p:notes>
 </file>
 
-<file path=ppt/notesSlides/notesSlide13.xml><?xml version="1.0" encoding="utf-8"?>
-<p:notes xmlns:a="http://schemas.openxmlformats.org/drawingml/2006/main" xmlns:r="http://schemas.openxmlformats.org/officeDocument/2006/relationships" xmlns:p="http://schemas.openxmlformats.org/presentationml/2006/main">
-  <p:cSld>
-    <p:spTree>
-      <p:nvGrpSpPr>
-        <p:cNvPr id="1" name=""/>
-        <p:cNvGrpSpPr/>
-        <p:nvPr/>
-      </p:nvGrpSpPr>
-      <p:grpSpPr>
-        <a:xfrm>
-          <a:off x="0" y="0"/>
-          <a:ext cx="0" cy="0"/>
-          <a:chOff x="0" y="0"/>
-          <a:chExt cx="0" cy="0"/>
-        </a:xfrm>
-      </p:grpSpPr>
-      <p:sp>
-        <p:nvSpPr>
-          <p:cNvPr id="2" name="Slide Image Placeholder 1"/>
-          <p:cNvSpPr>
-            <a:spLocks noGrp="1" noRot="1" noChangeAspect="1"/>
-          </p:cNvSpPr>
-          <p:nvPr>
-            <p:ph type="sldImg"/>
-          </p:nvPr>
-        </p:nvSpPr>
-        <p:spPr/>
-      </p:sp>
-      <p:sp>
-        <p:nvSpPr>
-          <p:cNvPr id="3" name="Notes Placeholder 2"/>
-          <p:cNvSpPr>
-            <a:spLocks noGrp="1"/>
-          </p:cNvSpPr>
-          <p:nvPr>
-            <p:ph type="body" idx="1"/>
-          </p:nvPr>
-        </p:nvSpPr>
-        <p:spPr/>
-        <p:txBody>
-          <a:bodyPr/>
-          <a:lstStyle/>
-          <a:p>
-            <a:r>
-              <a:rPr lang="en-US" dirty="0"/>
-              <a:t>Close with action: run one workflow, measure outcomes, and scale deliberately.</a:t>
-            </a:r>
-          </a:p>
-        </p:txBody>
-      </p:sp>
-      <p:sp>
-        <p:nvSpPr>
-          <p:cNvPr id="4" name="Slide Number Placeholder 3"/>
-          <p:cNvSpPr>
-            <a:spLocks noGrp="1"/>
-          </p:cNvSpPr>
-          <p:nvPr>
-            <p:ph type="sldNum" sz="quarter" idx="10"/>
-          </p:nvPr>
-        </p:nvSpPr>
-        <p:spPr/>
-        <p:txBody>
-          <a:bodyPr/>
-          <a:lstStyle/>
-          <a:p>
-            <a:fld id="{F7021451-1387-4CA6-816F-3879F97B5CBC}" type="slidenum">
-              <a:rPr lang="en-US"/>
-              <a:t>13</a:t>
-            </a:fld>
-            <a:endParaRPr lang="en-US"/>
-          </a:p>
-        </p:txBody>
-      </p:sp>
-    </p:spTree>
-    <p:extLst>
-      <p:ext uri="{BB962C8B-B14F-4D97-AF65-F5344CB8AC3E}">
-        <p14:creationId xmlns:p14="http://schemas.microsoft.com/office/powerpoint/2010/main" val="1024086991"/>
-      </p:ext>
-    </p:extLst>
-  </p:cSld>
-  <p:clrMapOvr>
-    <a:masterClrMapping/>
-  </p:clrMapOvr>
-</p:notes>
-</file>
-
 <file path=ppt/notesSlides/notesSlide2.xml><?xml version="1.0" encoding="utf-8"?>
 <p:notes xmlns:a="http://schemas.openxmlformats.org/drawingml/2006/main" xmlns:r="http://schemas.openxmlformats.org/officeDocument/2006/relationships" xmlns:p="http://schemas.openxmlformats.org/presentationml/2006/main">
   <p:cSld>
@@ -2126,24 +2039,104 @@
       </p:sp>
       <p:sp>
         <p:nvSpPr>
-          <p:cNvPr id="3" name="Shape 1"/>
-          <p:cNvSpPr/>
-          <p:nvPr/>
-        </p:nvSpPr>
-        <p:spPr>
-          <a:xfrm>
-            <a:off x="6355080" y="0"/>
-            <a:ext cx="6080760" cy="6949440"/>
-          </a:xfrm>
-          <a:prstGeom prst="rect">
-            <a:avLst/>
-          </a:prstGeom>
-          <a:solidFill>
-            <a:srgbClr val="0078D3"/>
-          </a:solidFill>
-          <a:ln w="12700">
+          <p:cNvPr id="5" name="Text 2"/>
+          <p:cNvSpPr/>
+          <p:nvPr/>
+        </p:nvSpPr>
+        <p:spPr>
+          <a:xfrm>
+            <a:off x="685800" y="914400"/>
+            <a:ext cx="10348546" cy="1234440"/>
+          </a:xfrm>
+          <a:prstGeom prst="rect">
+            <a:avLst/>
+          </a:prstGeom>
+          <a:noFill/>
+          <a:ln/>
+        </p:spPr>
+        <p:txBody>
+          <a:bodyPr wrap="square" lIns="0" tIns="12700" rIns="0" bIns="12700" rtlCol="0" anchor="ctr">
+            <a:normAutofit fontScale="92500"/>
+          </a:bodyPr>
+          <a:lstStyle/>
+          <a:p>
+            <a:pPr marL="0" indent="0">
+              <a:buNone/>
+            </a:pPr>
+            <a:r>
+              <a:rPr lang="en-US" sz="4800" b="1" dirty="0">
+                <a:solidFill>
+                  <a:srgbClr val="FFFFFF"/>
+                </a:solidFill>
+              </a:rPr>
+              <a:t>GitHub Copilot for Data Professionals</a:t>
+            </a:r>
+            <a:endParaRPr lang="en-US" sz="4800" dirty="0"/>
+          </a:p>
+        </p:txBody>
+      </p:sp>
+      <p:sp>
+        <p:nvSpPr>
+          <p:cNvPr id="6" name="Text 3"/>
+          <p:cNvSpPr/>
+          <p:nvPr/>
+        </p:nvSpPr>
+        <p:spPr>
+          <a:xfrm>
+            <a:off x="746291" y="1666600"/>
+            <a:ext cx="9512222" cy="731520"/>
+          </a:xfrm>
+          <a:prstGeom prst="rect">
+            <a:avLst/>
+          </a:prstGeom>
+          <a:noFill/>
+          <a:ln/>
+        </p:spPr>
+        <p:txBody>
+          <a:bodyPr wrap="square" lIns="0" tIns="12700" rIns="0" bIns="12700" rtlCol="0" anchor="ctr">
+            <a:normAutofit/>
+          </a:bodyPr>
+          <a:lstStyle/>
+          <a:p>
+            <a:pPr marL="0" indent="0">
+              <a:buNone/>
+            </a:pPr>
+            <a:r>
+              <a:rPr lang="en-US" sz="2300" b="1" dirty="0">
+                <a:solidFill>
+                  <a:srgbClr val="50E6FF"/>
+                </a:solidFill>
+              </a:rPr>
+              <a:t>A supply-chain data workflow: from raw signals to trusted decisions</a:t>
+            </a:r>
+            <a:endParaRPr lang="en-US" sz="2300" dirty="0"/>
+          </a:p>
+        </p:txBody>
+      </p:sp>
+      <p:sp>
+        <p:nvSpPr>
+          <p:cNvPr id="8" name="Shape 5"/>
+          <p:cNvSpPr/>
+          <p:nvPr/>
+        </p:nvSpPr>
+        <p:spPr>
+          <a:xfrm>
+            <a:off x="731520" y="4553712"/>
+            <a:ext cx="438912" cy="438912"/>
+          </a:xfrm>
+          <a:prstGeom prst="roundRect">
+            <a:avLst>
+              <a:gd name="adj" fmla="val 8333"/>
+            </a:avLst>
+          </a:prstGeom>
+          <a:solidFill>
+            <a:srgbClr val="FFFFFF">
+              <a:alpha val="92000"/>
+            </a:srgbClr>
+          </a:solidFill>
+          <a:ln w="6350">
             <a:solidFill>
-              <a:srgbClr val="0078D3"/>
+              <a:srgbClr val="D0D7DE"/>
             </a:solidFill>
             <a:prstDash val="solid"/>
           </a:ln>
@@ -2158,7 +2151,7 @@
       </p:sp>
       <p:pic>
         <p:nvPicPr>
-          <p:cNvPr id="4" name="Image 0" descr="/home/jordanbean/source/repos/github-copilot-for-data-professionals/deck/assets/hero-data-copilot.png"/>
+          <p:cNvPr id="9" name="Image 1" descr="/home/jordanbean/source/repos/github-copilot-for-data-professionals/deck/assets/icons/github-mark.png"/>
           <p:cNvPicPr>
             <a:picLocks noChangeAspect="1"/>
           </p:cNvPicPr>
@@ -2172,8 +2165,8 @@
         </p:blipFill>
         <p:spPr>
           <a:xfrm>
-            <a:off x="6537960" y="685800"/>
-            <a:ext cx="5623560" cy="3794760"/>
+            <a:off x="749808" y="4572000"/>
+            <a:ext cx="402336" cy="402336"/>
           </a:xfrm>
           <a:prstGeom prst="rect">
             <a:avLst/>
@@ -2182,127 +2175,13 @@
       </p:pic>
       <p:sp>
         <p:nvSpPr>
-          <p:cNvPr id="5" name="Text 2"/>
-          <p:cNvSpPr/>
-          <p:nvPr/>
-        </p:nvSpPr>
-        <p:spPr>
-          <a:xfrm>
-            <a:off x="685800" y="914400"/>
-            <a:ext cx="5349240" cy="1234440"/>
-          </a:xfrm>
-          <a:prstGeom prst="rect">
-            <a:avLst/>
-          </a:prstGeom>
-          <a:noFill/>
-          <a:ln/>
-        </p:spPr>
-        <p:txBody>
-          <a:bodyPr wrap="square" lIns="0" tIns="12700" rIns="0" bIns="12700" rtlCol="0" anchor="ctr">
-            <a:normAutofit/>
-          </a:bodyPr>
-          <a:lstStyle/>
-          <a:p>
-            <a:pPr marL="0" indent="0">
-              <a:buNone/>
-            </a:pPr>
-            <a:r>
-              <a:rPr lang="en-US" sz="4800" b="1" dirty="0">
-                <a:solidFill>
-                  <a:srgbClr val="FFFFFF"/>
-                </a:solidFill>
-              </a:rPr>
-              <a:t>GitHub Copilot for Data Professionals</a:t>
-            </a:r>
-            <a:endParaRPr lang="en-US" sz="4800" dirty="0"/>
-          </a:p>
-        </p:txBody>
-      </p:sp>
-      <p:sp>
-        <p:nvSpPr>
-          <p:cNvPr id="6" name="Text 3"/>
-          <p:cNvSpPr/>
-          <p:nvPr/>
-        </p:nvSpPr>
-        <p:spPr>
-          <a:xfrm>
-            <a:off x="713232" y="2331720"/>
-            <a:ext cx="5120640" cy="731520"/>
-          </a:xfrm>
-          <a:prstGeom prst="rect">
-            <a:avLst/>
-          </a:prstGeom>
-          <a:noFill/>
-          <a:ln/>
-        </p:spPr>
-        <p:txBody>
-          <a:bodyPr wrap="square" lIns="0" tIns="12700" rIns="0" bIns="12700" rtlCol="0" anchor="ctr">
-            <a:normAutofit/>
-          </a:bodyPr>
-          <a:lstStyle/>
-          <a:p>
-            <a:pPr marL="0" indent="0">
-              <a:buNone/>
-            </a:pPr>
-            <a:r>
-              <a:rPr lang="en-US" sz="2300" b="1" dirty="0">
-                <a:solidFill>
-                  <a:srgbClr val="50E6FF"/>
-                </a:solidFill>
-              </a:rPr>
-              <a:t>A supply-chain data workflow: from raw signals to trusted decisions</a:t>
-            </a:r>
-            <a:endParaRPr lang="en-US" sz="2300" dirty="0"/>
-          </a:p>
-        </p:txBody>
-      </p:sp>
-      <p:sp>
-        <p:nvSpPr>
-          <p:cNvPr id="7" name="Text 4"/>
-          <p:cNvSpPr/>
-          <p:nvPr/>
-        </p:nvSpPr>
-        <p:spPr>
-          <a:xfrm>
-            <a:off x="731520" y="3200400"/>
-            <a:ext cx="5166360" cy="1051560"/>
-          </a:xfrm>
-          <a:prstGeom prst="rect">
-            <a:avLst/>
-          </a:prstGeom>
-          <a:noFill/>
-          <a:ln/>
-        </p:spPr>
-        <p:txBody>
-          <a:bodyPr wrap="square" lIns="254" tIns="12700" rIns="254" bIns="12700" rtlCol="0" anchor="ctr">
-            <a:normAutofit/>
-          </a:bodyPr>
-          <a:lstStyle/>
-          <a:p>
-            <a:pPr marL="0" indent="0">
-              <a:buNone/>
-            </a:pPr>
-            <a:r>
-              <a:rPr lang="en-US" sz="1700" dirty="0">
-                <a:solidFill>
-                  <a:srgbClr val="FFFFFF"/>
-                </a:solidFill>
-              </a:rPr>
-              <a:t>GitHub Copilot accelerates repetitive supply-chain data work in Python, PySpark, SQL, and notebooks while teams keep full control over correctness.</a:t>
-            </a:r>
-            <a:endParaRPr lang="en-US" sz="1700" dirty="0"/>
-          </a:p>
-        </p:txBody>
-      </p:sp>
-      <p:sp>
-        <p:nvSpPr>
-          <p:cNvPr id="8" name="Shape 5"/>
-          <p:cNvSpPr/>
-          <p:nvPr/>
-        </p:nvSpPr>
-        <p:spPr>
-          <a:xfrm>
-            <a:off x="731520" y="4553712"/>
+          <p:cNvPr id="10" name="Shape 6"/>
+          <p:cNvSpPr/>
+          <p:nvPr/>
+        </p:nvSpPr>
+        <p:spPr>
+          <a:xfrm>
+            <a:off x="1298448" y="4553712"/>
             <a:ext cx="438912" cy="438912"/>
           </a:xfrm>
           <a:prstGeom prst="roundRect">
@@ -2332,7 +2211,7 @@
       </p:sp>
       <p:pic>
         <p:nvPicPr>
-          <p:cNvPr id="9" name="Image 1" descr="/home/jordanbean/source/repos/github-copilot-for-data-professionals/deck/assets/icons/github-mark.png"/>
+          <p:cNvPr id="11" name="Image 2" descr="/home/jordanbean/source/repos/github-copilot-for-data-professionals/deck/assets/icons/github-copilot.png"/>
           <p:cNvPicPr>
             <a:picLocks noChangeAspect="1"/>
           </p:cNvPicPr>
@@ -2346,7 +2225,7 @@
         </p:blipFill>
         <p:spPr>
           <a:xfrm>
-            <a:off x="749808" y="4572000"/>
+            <a:off x="1316736" y="4572000"/>
             <a:ext cx="402336" cy="402336"/>
           </a:xfrm>
           <a:prstGeom prst="rect">
@@ -2356,13 +2235,13 @@
       </p:pic>
       <p:sp>
         <p:nvSpPr>
-          <p:cNvPr id="10" name="Shape 6"/>
-          <p:cNvSpPr/>
-          <p:nvPr/>
-        </p:nvSpPr>
-        <p:spPr>
-          <a:xfrm>
-            <a:off x="1298448" y="4553712"/>
+          <p:cNvPr id="12" name="Shape 7"/>
+          <p:cNvSpPr/>
+          <p:nvPr/>
+        </p:nvSpPr>
+        <p:spPr>
+          <a:xfrm>
+            <a:off x="1865376" y="4553712"/>
             <a:ext cx="438912" cy="438912"/>
           </a:xfrm>
           <a:prstGeom prst="roundRect">
@@ -2392,66 +2271,6 @@
       </p:sp>
       <p:pic>
         <p:nvPicPr>
-          <p:cNvPr id="11" name="Image 2" descr="/home/jordanbean/source/repos/github-copilot-for-data-professionals/deck/assets/icons/github-copilot.png"/>
-          <p:cNvPicPr>
-            <a:picLocks noChangeAspect="1"/>
-          </p:cNvPicPr>
-          <p:nvPr/>
-        </p:nvPicPr>
-        <p:blipFill>
-          <a:blip r:embed="rId5"/>
-          <a:stretch>
-            <a:fillRect/>
-          </a:stretch>
-        </p:blipFill>
-        <p:spPr>
-          <a:xfrm>
-            <a:off x="1316736" y="4572000"/>
-            <a:ext cx="402336" cy="402336"/>
-          </a:xfrm>
-          <a:prstGeom prst="rect">
-            <a:avLst/>
-          </a:prstGeom>
-        </p:spPr>
-      </p:pic>
-      <p:sp>
-        <p:nvSpPr>
-          <p:cNvPr id="12" name="Shape 7"/>
-          <p:cNvSpPr/>
-          <p:nvPr/>
-        </p:nvSpPr>
-        <p:spPr>
-          <a:xfrm>
-            <a:off x="1865376" y="4553712"/>
-            <a:ext cx="438912" cy="438912"/>
-          </a:xfrm>
-          <a:prstGeom prst="roundRect">
-            <a:avLst>
-              <a:gd name="adj" fmla="val 8333"/>
-            </a:avLst>
-          </a:prstGeom>
-          <a:solidFill>
-            <a:srgbClr val="FFFFFF">
-              <a:alpha val="92000"/>
-            </a:srgbClr>
-          </a:solidFill>
-          <a:ln w="6350">
-            <a:solidFill>
-              <a:srgbClr val="D0D7DE"/>
-            </a:solidFill>
-            <a:prstDash val="solid"/>
-          </a:ln>
-        </p:spPr>
-        <p:txBody>
-          <a:bodyPr/>
-          <a:lstStyle/>
-          <a:p>
-            <a:endParaRPr lang="en-US"/>
-          </a:p>
-        </p:txBody>
-      </p:sp>
-      <p:pic>
-        <p:nvPicPr>
           <p:cNvPr id="13" name="Image 3" descr="/home/jordanbean/source/repos/github-copilot-for-data-professionals/deck/assets/icons/microsoft-fabric.png"/>
           <p:cNvPicPr>
             <a:picLocks noChangeAspect="1"/>
@@ -2459,7 +2278,7 @@
           <p:nvPr/>
         </p:nvPicPr>
         <p:blipFill>
-          <a:blip r:embed="rId6"/>
+          <a:blip r:embed="rId5"/>
           <a:stretch>
             <a:fillRect/>
           </a:stretch>
@@ -2902,7 +2721,7 @@
         </p:spPr>
         <p:txBody>
           <a:bodyPr wrap="square" lIns="254" tIns="12700" rIns="254" bIns="12700" rtlCol="0" anchor="ctr">
-            <a:normAutofit/>
+            <a:normAutofit lnSpcReduction="10000"/>
           </a:bodyPr>
           <a:lstStyle/>
           <a:p>
@@ -3282,7 +3101,7 @@
         </p:spPr>
         <p:txBody>
           <a:bodyPr wrap="square" lIns="0" tIns="12700" rIns="0" bIns="12700" rtlCol="0" anchor="ctr">
-            <a:normAutofit/>
+            <a:normAutofit fontScale="85000" lnSpcReduction="10000"/>
           </a:bodyPr>
           <a:lstStyle/>
           <a:p>
@@ -4101,148 +3920,6 @@
           </a:p>
         </p:txBody>
       </p:sp>
-      <p:sp>
-        <p:nvSpPr>
-          <p:cNvPr id="23" name="Shape 19"/>
-          <p:cNvSpPr/>
-          <p:nvPr/>
-        </p:nvSpPr>
-        <p:spPr>
-          <a:xfrm>
-            <a:off x="713232" y="5806440"/>
-            <a:ext cx="10972800" cy="713232"/>
-          </a:xfrm>
-          <a:prstGeom prst="roundRect">
-            <a:avLst>
-              <a:gd name="adj" fmla="val 10256"/>
-            </a:avLst>
-          </a:prstGeom>
-          <a:solidFill>
-            <a:srgbClr val="EBEBEB"/>
-          </a:solidFill>
-          <a:ln w="15240">
-            <a:solidFill>
-              <a:srgbClr val="000041"/>
-            </a:solidFill>
-            <a:prstDash val="solid"/>
-          </a:ln>
-        </p:spPr>
-        <p:txBody>
-          <a:bodyPr/>
-          <a:lstStyle/>
-          <a:p>
-            <a:endParaRPr lang="en-US"/>
-          </a:p>
-        </p:txBody>
-      </p:sp>
-      <p:sp>
-        <p:nvSpPr>
-          <p:cNvPr id="24" name="Shape 20"/>
-          <p:cNvSpPr/>
-          <p:nvPr/>
-        </p:nvSpPr>
-        <p:spPr>
-          <a:xfrm>
-            <a:off x="713232" y="5806440"/>
-            <a:ext cx="128016" cy="713232"/>
-          </a:xfrm>
-          <a:prstGeom prst="rect">
-            <a:avLst/>
-          </a:prstGeom>
-          <a:solidFill>
-            <a:srgbClr val="000041"/>
-          </a:solidFill>
-          <a:ln w="12700">
-            <a:solidFill>
-              <a:srgbClr val="000041"/>
-            </a:solidFill>
-            <a:prstDash val="solid"/>
-          </a:ln>
-        </p:spPr>
-        <p:txBody>
-          <a:bodyPr/>
-          <a:lstStyle/>
-          <a:p>
-            <a:endParaRPr lang="en-US"/>
-          </a:p>
-        </p:txBody>
-      </p:sp>
-      <p:sp>
-        <p:nvSpPr>
-          <p:cNvPr id="25" name="Text 21"/>
-          <p:cNvSpPr/>
-          <p:nvPr/>
-        </p:nvSpPr>
-        <p:spPr>
-          <a:xfrm>
-            <a:off x="987552" y="5952744"/>
-            <a:ext cx="10561320" cy="384048"/>
-          </a:xfrm>
-          <a:prstGeom prst="rect">
-            <a:avLst/>
-          </a:prstGeom>
-          <a:noFill/>
-          <a:ln/>
-        </p:spPr>
-        <p:txBody>
-          <a:bodyPr wrap="square" lIns="0" tIns="12700" rIns="0" bIns="12700" rtlCol="0" anchor="ctr">
-            <a:normAutofit/>
-          </a:bodyPr>
-          <a:lstStyle/>
-          <a:p>
-            <a:pPr marL="0" indent="0">
-              <a:buNone/>
-            </a:pPr>
-            <a:r>
-              <a:rPr lang="en-US" sz="1100" b="1" dirty="0">
-                <a:solidFill>
-                  <a:srgbClr val="000041"/>
-                </a:solidFill>
-              </a:rPr>
-              <a:t>Practical tip</a:t>
-            </a:r>
-            <a:endParaRPr lang="en-US" sz="1100" dirty="0"/>
-          </a:p>
-        </p:txBody>
-      </p:sp>
-      <p:sp>
-        <p:nvSpPr>
-          <p:cNvPr id="26" name="Text 22"/>
-          <p:cNvSpPr/>
-          <p:nvPr/>
-        </p:nvSpPr>
-        <p:spPr>
-          <a:xfrm>
-            <a:off x="987552" y="6336792"/>
-            <a:ext cx="10561320" cy="219456"/>
-          </a:xfrm>
-          <a:prstGeom prst="rect">
-            <a:avLst/>
-          </a:prstGeom>
-          <a:noFill/>
-          <a:ln/>
-        </p:spPr>
-        <p:txBody>
-          <a:bodyPr wrap="square" lIns="254" tIns="12700" rIns="254" bIns="12700" rtlCol="0" anchor="ctr">
-            <a:normAutofit/>
-          </a:bodyPr>
-          <a:lstStyle/>
-          <a:p>
-            <a:pPr marL="0" indent="0">
-              <a:buNone/>
-            </a:pPr>
-            <a:r>
-              <a:rPr lang="en-US" sz="1100" dirty="0">
-                <a:solidFill>
-                  <a:srgbClr val="000000"/>
-                </a:solidFill>
-              </a:rPr>
-              <a:t>End each prompt with: explain assumptions and propose one safer alternative.</a:t>
-            </a:r>
-            <a:endParaRPr lang="en-US" sz="1100" dirty="0"/>
-          </a:p>
-        </p:txBody>
-      </p:sp>
     </p:spTree>
   </p:cSld>
   <p:clrMapOvr>
@@ -5039,15 +4716,7 @@
 
 <file path=ppt/slides/slide13.xml><?xml version="1.0" encoding="utf-8"?>
 <p:sld xmlns:a="http://schemas.openxmlformats.org/drawingml/2006/main" xmlns:r="http://schemas.openxmlformats.org/officeDocument/2006/relationships" xmlns:p="http://schemas.openxmlformats.org/presentationml/2006/main">
-  <p:cSld name="Slide 15">
-    <p:bg>
-      <p:bgPr>
-        <a:solidFill>
-          <a:srgbClr val="000041"/>
-        </a:solidFill>
-        <a:effectLst/>
-      </p:bgPr>
-    </p:bg>
+  <p:cSld>
     <p:spTree>
       <p:nvGrpSpPr>
         <p:cNvPr id="1" name=""/>
@@ -5064,14 +4733,20 @@
       </p:grpSpPr>
       <p:sp>
         <p:nvSpPr>
-          <p:cNvPr id="2" name="Text 0"/>
-          <p:cNvSpPr/>
-          <p:nvPr/>
-        </p:nvSpPr>
-        <p:spPr>
-          <a:xfrm>
-            <a:off x="713232" y="822960"/>
-            <a:ext cx="7132320" cy="822960"/>
+          <p:cNvPr id="4" name="Text 0">
+            <a:extLst>
+              <a:ext uri="{FF2B5EF4-FFF2-40B4-BE49-F238E27FC236}">
+                <a16:creationId xmlns:a16="http://schemas.microsoft.com/office/drawing/2014/main" id="{50C2843D-B81A-BFA7-F044-F8536623C4B9}"/>
+              </a:ext>
+            </a:extLst>
+          </p:cNvPr>
+          <p:cNvSpPr/>
+          <p:nvPr/>
+        </p:nvSpPr>
+        <p:spPr>
+          <a:xfrm>
+            <a:off x="566928" y="310896"/>
+            <a:ext cx="10424160" cy="658368"/>
           </a:xfrm>
           <a:prstGeom prst="rect">
             <a:avLst/>
@@ -5089,332 +4764,26 @@
               <a:buNone/>
             </a:pPr>
             <a:r>
-              <a:rPr lang="en-US" sz="4600" b="1" dirty="0">
+              <a:rPr lang="en-US" sz="3200" b="1" dirty="0">
                 <a:solidFill>
-                  <a:srgbClr val="FFFFFF"/>
+                  <a:srgbClr val="000041"/>
                 </a:solidFill>
+                <a:latin typeface="Segoe UI Semibold" pitchFamily="34" charset="0"/>
+                <a:ea typeface="Segoe UI Semibold" pitchFamily="34" charset="-122"/>
+                <a:cs typeface="Segoe UI Semibold" pitchFamily="34" charset="-120"/>
               </a:rPr>
-              <a:t>Start with one real workflow this week</a:t>
-            </a:r>
-            <a:endParaRPr lang="en-US" sz="4600" dirty="0"/>
-          </a:p>
-        </p:txBody>
-      </p:sp>
-      <p:sp>
-        <p:nvSpPr>
-          <p:cNvPr id="3" name="Text 1"/>
-          <p:cNvSpPr/>
-          <p:nvPr/>
-        </p:nvSpPr>
-        <p:spPr>
-          <a:xfrm>
-            <a:off x="731520" y="1828800"/>
-            <a:ext cx="6949440" cy="1097280"/>
-          </a:xfrm>
-          <a:prstGeom prst="rect">
-            <a:avLst/>
-          </a:prstGeom>
-          <a:noFill/>
-          <a:ln/>
-        </p:spPr>
-        <p:txBody>
-          <a:bodyPr wrap="square" lIns="0" tIns="12700" rIns="0" bIns="12700" rtlCol="0" anchor="ctr">
-            <a:normAutofit/>
-          </a:bodyPr>
-          <a:lstStyle/>
-          <a:p>
-            <a:pPr marL="0" indent="0">
-              <a:buNone/>
-            </a:pPr>
-            <a:r>
-              <a:rPr lang="en-US" sz="2100" dirty="0">
-                <a:solidFill>
-                  <a:srgbClr val="50E6FF"/>
-                </a:solidFill>
-              </a:rPr>
-              <a:t>Use this repo to run the full supply-chain data storyline from generation to risk prediction, then adapt prompts and guardrails for your own team.</a:t>
-            </a:r>
-            <a:endParaRPr lang="en-US" sz="2100" dirty="0"/>
-          </a:p>
-        </p:txBody>
-      </p:sp>
-      <p:pic>
-        <p:nvPicPr>
-          <p:cNvPr id="4" name="Image 0" descr="/home/jordanbean/source/repos/github-copilot-for-data-professionals/deck/assets/workflow-map.png"/>
-          <p:cNvPicPr>
-            <a:picLocks noChangeAspect="1"/>
-          </p:cNvPicPr>
-          <p:nvPr/>
-        </p:nvPicPr>
-        <p:blipFill>
-          <a:blip r:embed="rId3"/>
-          <a:stretch>
-            <a:fillRect/>
-          </a:stretch>
-        </p:blipFill>
-        <p:spPr>
-          <a:xfrm>
-            <a:off x="6583680" y="914400"/>
-            <a:ext cx="5440680" cy="3931920"/>
-          </a:xfrm>
-          <a:prstGeom prst="rect">
-            <a:avLst/>
-          </a:prstGeom>
-        </p:spPr>
-      </p:pic>
-      <p:sp>
-        <p:nvSpPr>
-          <p:cNvPr id="5" name="Shape 2"/>
-          <p:cNvSpPr/>
-          <p:nvPr/>
-        </p:nvSpPr>
-        <p:spPr>
-          <a:xfrm>
-            <a:off x="731520" y="3410712"/>
-            <a:ext cx="420624" cy="420624"/>
-          </a:xfrm>
-          <a:prstGeom prst="roundRect">
-            <a:avLst>
-              <a:gd name="adj" fmla="val 8696"/>
-            </a:avLst>
-          </a:prstGeom>
-          <a:solidFill>
-            <a:srgbClr val="FFFFFF">
-              <a:alpha val="92000"/>
-            </a:srgbClr>
-          </a:solidFill>
-          <a:ln w="6350">
-            <a:solidFill>
-              <a:srgbClr val="D0D7DE"/>
-            </a:solidFill>
-            <a:prstDash val="solid"/>
-          </a:ln>
-        </p:spPr>
-        <p:txBody>
-          <a:bodyPr/>
-          <a:lstStyle/>
-          <a:p>
-            <a:endParaRPr lang="en-US"/>
-          </a:p>
-        </p:txBody>
-      </p:sp>
-      <p:pic>
-        <p:nvPicPr>
-          <p:cNvPr id="6" name="Image 1" descr="/home/jordanbean/source/repos/github-copilot-for-data-professionals/deck/assets/icons/github-mark.png"/>
-          <p:cNvPicPr>
-            <a:picLocks noChangeAspect="1"/>
-          </p:cNvPicPr>
-          <p:nvPr/>
-        </p:nvPicPr>
-        <p:blipFill>
-          <a:blip r:embed="rId4"/>
-          <a:stretch>
-            <a:fillRect/>
-          </a:stretch>
-        </p:blipFill>
-        <p:spPr>
-          <a:xfrm>
-            <a:off x="749808" y="3429000"/>
-            <a:ext cx="384048" cy="384048"/>
-          </a:xfrm>
-          <a:prstGeom prst="rect">
-            <a:avLst/>
-          </a:prstGeom>
-        </p:spPr>
-      </p:pic>
-      <p:sp>
-        <p:nvSpPr>
-          <p:cNvPr id="7" name="Shape 3"/>
-          <p:cNvSpPr/>
-          <p:nvPr/>
-        </p:nvSpPr>
-        <p:spPr>
-          <a:xfrm>
-            <a:off x="1261872" y="3410712"/>
-            <a:ext cx="420624" cy="420624"/>
-          </a:xfrm>
-          <a:prstGeom prst="roundRect">
-            <a:avLst>
-              <a:gd name="adj" fmla="val 8696"/>
-            </a:avLst>
-          </a:prstGeom>
-          <a:solidFill>
-            <a:srgbClr val="FFFFFF">
-              <a:alpha val="92000"/>
-            </a:srgbClr>
-          </a:solidFill>
-          <a:ln w="6350">
-            <a:solidFill>
-              <a:srgbClr val="D0D7DE"/>
-            </a:solidFill>
-            <a:prstDash val="solid"/>
-          </a:ln>
-        </p:spPr>
-        <p:txBody>
-          <a:bodyPr/>
-          <a:lstStyle/>
-          <a:p>
-            <a:endParaRPr lang="en-US"/>
-          </a:p>
-        </p:txBody>
-      </p:sp>
-      <p:pic>
-        <p:nvPicPr>
-          <p:cNvPr id="8" name="Image 2" descr="/home/jordanbean/source/repos/github-copilot-for-data-professionals/deck/assets/icons/github-copilot.png"/>
-          <p:cNvPicPr>
-            <a:picLocks noChangeAspect="1"/>
-          </p:cNvPicPr>
-          <p:nvPr/>
-        </p:nvPicPr>
-        <p:blipFill>
-          <a:blip r:embed="rId5"/>
-          <a:stretch>
-            <a:fillRect/>
-          </a:stretch>
-        </p:blipFill>
-        <p:spPr>
-          <a:xfrm>
-            <a:off x="1280160" y="3429000"/>
-            <a:ext cx="384048" cy="384048"/>
-          </a:xfrm>
-          <a:prstGeom prst="rect">
-            <a:avLst/>
-          </a:prstGeom>
-        </p:spPr>
-      </p:pic>
-      <p:sp>
-        <p:nvSpPr>
-          <p:cNvPr id="9" name="Shape 4"/>
-          <p:cNvSpPr/>
-          <p:nvPr/>
-        </p:nvSpPr>
-        <p:spPr>
-          <a:xfrm>
-            <a:off x="1792224" y="3410712"/>
-            <a:ext cx="420624" cy="420624"/>
-          </a:xfrm>
-          <a:prstGeom prst="roundRect">
-            <a:avLst>
-              <a:gd name="adj" fmla="val 8696"/>
-            </a:avLst>
-          </a:prstGeom>
-          <a:solidFill>
-            <a:srgbClr val="FFFFFF">
-              <a:alpha val="92000"/>
-            </a:srgbClr>
-          </a:solidFill>
-          <a:ln w="6350">
-            <a:solidFill>
-              <a:srgbClr val="D0D7DE"/>
-            </a:solidFill>
-            <a:prstDash val="solid"/>
-          </a:ln>
-        </p:spPr>
-        <p:txBody>
-          <a:bodyPr/>
-          <a:lstStyle/>
-          <a:p>
-            <a:endParaRPr lang="en-US"/>
-          </a:p>
-        </p:txBody>
-      </p:sp>
-      <p:pic>
-        <p:nvPicPr>
-          <p:cNvPr id="10" name="Image 3" descr="/home/jordanbean/source/repos/github-copilot-for-data-professionals/deck/assets/icons/microsoft-fabric.png"/>
-          <p:cNvPicPr>
-            <a:picLocks noChangeAspect="1"/>
-          </p:cNvPicPr>
-          <p:nvPr/>
-        </p:nvPicPr>
-        <p:blipFill>
-          <a:blip r:embed="rId6"/>
-          <a:stretch>
-            <a:fillRect/>
-          </a:stretch>
-        </p:blipFill>
-        <p:spPr>
-          <a:xfrm>
-            <a:off x="1810512" y="3429000"/>
-            <a:ext cx="384048" cy="384048"/>
-          </a:xfrm>
-          <a:prstGeom prst="rect">
-            <a:avLst/>
-          </a:prstGeom>
-        </p:spPr>
-      </p:pic>
-      <p:sp>
-        <p:nvSpPr>
-          <p:cNvPr id="11" name="Shape 5"/>
-          <p:cNvSpPr/>
-          <p:nvPr/>
-        </p:nvSpPr>
-        <p:spPr>
-          <a:xfrm>
-            <a:off x="749808" y="4206240"/>
-            <a:ext cx="10972800" cy="1005840"/>
-          </a:xfrm>
-          <a:prstGeom prst="roundRect">
-            <a:avLst>
-              <a:gd name="adj" fmla="val 7273"/>
-            </a:avLst>
-          </a:prstGeom>
-          <a:solidFill>
-            <a:srgbClr val="0078D3"/>
-          </a:solidFill>
-          <a:ln w="12700">
-            <a:solidFill>
-              <a:srgbClr val="0078D3"/>
-            </a:solidFill>
-            <a:prstDash val="solid"/>
-          </a:ln>
-        </p:spPr>
-        <p:txBody>
-          <a:bodyPr/>
-          <a:lstStyle/>
-          <a:p>
-            <a:endParaRPr lang="en-US"/>
-          </a:p>
-        </p:txBody>
-      </p:sp>
-      <p:sp>
-        <p:nvSpPr>
-          <p:cNvPr id="12" name="Text 6"/>
-          <p:cNvSpPr/>
-          <p:nvPr/>
-        </p:nvSpPr>
-        <p:spPr>
-          <a:xfrm>
-            <a:off x="987552" y="4526280"/>
-            <a:ext cx="10469880" cy="329184"/>
-          </a:xfrm>
-          <a:prstGeom prst="rect">
-            <a:avLst/>
-          </a:prstGeom>
-          <a:noFill/>
-          <a:ln/>
-        </p:spPr>
-        <p:txBody>
-          <a:bodyPr wrap="square" lIns="0" tIns="12700" rIns="0" bIns="12700" rtlCol="0" anchor="ctr">
-            <a:normAutofit/>
-          </a:bodyPr>
-          <a:lstStyle/>
-          <a:p>
-            <a:pPr marL="0" indent="0" algn="ctr">
-              <a:buNone/>
-            </a:pPr>
-            <a:r>
-              <a:rPr lang="en-US" sz="1800" b="1" dirty="0">
-                <a:solidFill>
-                  <a:srgbClr val="FFFFFF"/>
-                </a:solidFill>
-              </a:rPr>
-              <a:t>https://github.com/jordanbean-msft/github-copilot-for-data-professionals</a:t>
-            </a:r>
-            <a:endParaRPr lang="en-US" sz="1800" dirty="0"/>
+              <a:t>Questions</a:t>
+            </a:r>
+            <a:endParaRPr lang="en-US" sz="3200" dirty="0"/>
           </a:p>
         </p:txBody>
       </p:sp>
     </p:spTree>
+    <p:extLst>
+      <p:ext uri="{BB962C8B-B14F-4D97-AF65-F5344CB8AC3E}">
+        <p14:creationId xmlns:p14="http://schemas.microsoft.com/office/powerpoint/2010/main" val="2641808144"/>
+      </p:ext>
+    </p:extLst>
   </p:cSld>
   <p:clrMapOvr>
     <a:masterClrMapping/>
@@ -6399,7 +5768,7 @@
         </p:spPr>
         <p:txBody>
           <a:bodyPr wrap="square" lIns="0" tIns="12700" rIns="0" bIns="12700" rtlCol="0" anchor="ctr">
-            <a:normAutofit/>
+            <a:normAutofit lnSpcReduction="10000"/>
           </a:bodyPr>
           <a:lstStyle/>
           <a:p>
@@ -6437,7 +5806,7 @@
         </p:spPr>
         <p:txBody>
           <a:bodyPr wrap="square" lIns="0" tIns="12700" rIns="0" bIns="12700" rtlCol="0" anchor="ctr">
-            <a:normAutofit/>
+            <a:normAutofit lnSpcReduction="10000"/>
           </a:bodyPr>
           <a:lstStyle/>
           <a:p>
@@ -6475,7 +5844,7 @@
         </p:spPr>
         <p:txBody>
           <a:bodyPr wrap="square" lIns="0" tIns="12700" rIns="0" bIns="12700" rtlCol="0" anchor="ctr">
-            <a:normAutofit/>
+            <a:normAutofit lnSpcReduction="10000"/>
           </a:bodyPr>
           <a:lstStyle/>
           <a:p>
@@ -6547,7 +5916,7 @@
         </p:spPr>
         <p:txBody>
           <a:bodyPr wrap="square" lIns="0" tIns="12700" rIns="0" bIns="12700" rtlCol="0" anchor="ctr">
-            <a:normAutofit/>
+            <a:normAutofit lnSpcReduction="10000"/>
           </a:bodyPr>
           <a:lstStyle/>
           <a:p>
@@ -6585,7 +5954,7 @@
         </p:spPr>
         <p:txBody>
           <a:bodyPr wrap="square" lIns="0" tIns="12700" rIns="0" bIns="12700" rtlCol="0" anchor="ctr">
-            <a:normAutofit/>
+            <a:normAutofit lnSpcReduction="10000"/>
           </a:bodyPr>
           <a:lstStyle/>
           <a:p>
@@ -6623,7 +5992,7 @@
         </p:spPr>
         <p:txBody>
           <a:bodyPr wrap="square" lIns="0" tIns="12700" rIns="0" bIns="12700" rtlCol="0" anchor="ctr">
-            <a:normAutofit/>
+            <a:normAutofit lnSpcReduction="10000"/>
           </a:bodyPr>
           <a:lstStyle/>
           <a:p>
@@ -6695,7 +6064,7 @@
         </p:spPr>
         <p:txBody>
           <a:bodyPr wrap="square" lIns="0" tIns="12700" rIns="0" bIns="12700" rtlCol="0" anchor="ctr">
-            <a:normAutofit/>
+            <a:normAutofit lnSpcReduction="10000"/>
           </a:bodyPr>
           <a:lstStyle/>
           <a:p>
@@ -6733,7 +6102,7 @@
         </p:spPr>
         <p:txBody>
           <a:bodyPr wrap="square" lIns="0" tIns="12700" rIns="0" bIns="12700" rtlCol="0" anchor="ctr">
-            <a:normAutofit/>
+            <a:normAutofit lnSpcReduction="10000"/>
           </a:bodyPr>
           <a:lstStyle/>
           <a:p>
@@ -6771,7 +6140,7 @@
         </p:spPr>
         <p:txBody>
           <a:bodyPr wrap="square" lIns="0" tIns="12700" rIns="0" bIns="12700" rtlCol="0" anchor="ctr">
-            <a:normAutofit/>
+            <a:normAutofit lnSpcReduction="10000"/>
           </a:bodyPr>
           <a:lstStyle/>
           <a:p>
@@ -6843,7 +6212,7 @@
         </p:spPr>
         <p:txBody>
           <a:bodyPr wrap="square" lIns="0" tIns="12700" rIns="0" bIns="12700" rtlCol="0" anchor="ctr">
-            <a:normAutofit/>
+            <a:normAutofit lnSpcReduction="10000"/>
           </a:bodyPr>
           <a:lstStyle/>
           <a:p>
@@ -6881,7 +6250,7 @@
         </p:spPr>
         <p:txBody>
           <a:bodyPr wrap="square" lIns="0" tIns="12700" rIns="0" bIns="12700" rtlCol="0" anchor="ctr">
-            <a:normAutofit/>
+            <a:normAutofit lnSpcReduction="10000"/>
           </a:bodyPr>
           <a:lstStyle/>
           <a:p>
@@ -6919,7 +6288,7 @@
         </p:spPr>
         <p:txBody>
           <a:bodyPr wrap="square" lIns="0" tIns="12700" rIns="0" bIns="12700" rtlCol="0" anchor="ctr">
-            <a:normAutofit/>
+            <a:normAutofit lnSpcReduction="10000"/>
           </a:bodyPr>
           <a:lstStyle/>
           <a:p>
@@ -6991,7 +6360,7 @@
         </p:spPr>
         <p:txBody>
           <a:bodyPr wrap="square" lIns="0" tIns="12700" rIns="0" bIns="12700" rtlCol="0" anchor="ctr">
-            <a:normAutofit/>
+            <a:normAutofit lnSpcReduction="10000"/>
           </a:bodyPr>
           <a:lstStyle/>
           <a:p>
@@ -7029,7 +6398,7 @@
         </p:spPr>
         <p:txBody>
           <a:bodyPr wrap="square" lIns="0" tIns="12700" rIns="0" bIns="12700" rtlCol="0" anchor="ctr">
-            <a:normAutofit/>
+            <a:normAutofit lnSpcReduction="10000"/>
           </a:bodyPr>
           <a:lstStyle/>
           <a:p>
@@ -7067,7 +6436,7 @@
         </p:spPr>
         <p:txBody>
           <a:bodyPr wrap="square" lIns="0" tIns="12700" rIns="0" bIns="12700" rtlCol="0" anchor="ctr">
-            <a:normAutofit/>
+            <a:normAutofit lnSpcReduction="10000"/>
           </a:bodyPr>
           <a:lstStyle/>
           <a:p>
@@ -7139,7 +6508,7 @@
         </p:spPr>
         <p:txBody>
           <a:bodyPr wrap="square" lIns="0" tIns="12700" rIns="0" bIns="12700" rtlCol="0" anchor="ctr">
-            <a:normAutofit/>
+            <a:normAutofit lnSpcReduction="10000"/>
           </a:bodyPr>
           <a:lstStyle/>
           <a:p>
@@ -7177,7 +6546,7 @@
         </p:spPr>
         <p:txBody>
           <a:bodyPr wrap="square" lIns="0" tIns="12700" rIns="0" bIns="12700" rtlCol="0" anchor="ctr">
-            <a:normAutofit/>
+            <a:normAutofit lnSpcReduction="10000"/>
           </a:bodyPr>
           <a:lstStyle/>
           <a:p>
@@ -7215,7 +6584,7 @@
         </p:spPr>
         <p:txBody>
           <a:bodyPr wrap="square" lIns="0" tIns="12700" rIns="0" bIns="12700" rtlCol="0" anchor="ctr">
-            <a:normAutofit/>
+            <a:normAutofit lnSpcReduction="10000"/>
           </a:bodyPr>
           <a:lstStyle/>
           <a:p>
@@ -7286,7 +6655,7 @@
         </p:spPr>
         <p:txBody>
           <a:bodyPr wrap="square" lIns="0" tIns="12700" rIns="0" bIns="12700" rtlCol="0" anchor="ctr">
-            <a:normAutofit/>
+            <a:noAutofit/>
           </a:bodyPr>
           <a:lstStyle/>
           <a:p>
@@ -7294,7 +6663,7 @@
               <a:buNone/>
             </a:pPr>
             <a:r>
-              <a:rPr lang="en-US" sz="3300" b="1" dirty="0">
+              <a:rPr lang="en-US" sz="2800" b="1" dirty="0">
                 <a:solidFill>
                   <a:srgbClr val="000041"/>
                 </a:solidFill>
@@ -7304,49 +6673,13 @@
               </a:rPr>
               <a:t>Demo environment: GitHub + Copilot + Microsoft Fabric</a:t>
             </a:r>
-            <a:endParaRPr lang="en-US" sz="3300" dirty="0"/>
-          </a:p>
-        </p:txBody>
-      </p:sp>
-      <p:sp>
-        <p:nvSpPr>
-          <p:cNvPr id="3" name="Shape 1"/>
-          <p:cNvSpPr/>
-          <p:nvPr/>
-        </p:nvSpPr>
-        <p:spPr>
-          <a:xfrm>
-            <a:off x="676656" y="850392"/>
-            <a:ext cx="760781" cy="365760"/>
-          </a:xfrm>
-          <a:prstGeom prst="roundRect">
-            <a:avLst>
-              <a:gd name="adj" fmla="val 10000"/>
-            </a:avLst>
-          </a:prstGeom>
-          <a:solidFill>
-            <a:srgbClr val="FFFFFF">
-              <a:alpha val="92000"/>
-            </a:srgbClr>
-          </a:solidFill>
-          <a:ln w="6350">
-            <a:solidFill>
-              <a:srgbClr val="D0D7DE"/>
-            </a:solidFill>
-            <a:prstDash val="solid"/>
-          </a:ln>
-        </p:spPr>
-        <p:txBody>
-          <a:bodyPr/>
-          <a:lstStyle/>
-          <a:p>
-            <a:endParaRPr lang="en-US"/>
+            <a:endParaRPr lang="en-US" sz="2800" dirty="0"/>
           </a:p>
         </p:txBody>
       </p:sp>
       <p:pic>
         <p:nvPicPr>
-          <p:cNvPr id="4" name="Image 0" descr="/home/jordanbean/source/repos/github-copilot-for-data-professionals/deck/assets/icons/github-logo.png"/>
+          <p:cNvPr id="9" name="Image 3" descr="/home/jordanbean/source/repos/github-copilot-for-data-professionals/deck/assets/fabric-architecture.png"/>
           <p:cNvPicPr>
             <a:picLocks noChangeAspect="1"/>
           </p:cNvPicPr>
@@ -7360,150 +6693,6 @@
         </p:blipFill>
         <p:spPr>
           <a:xfrm>
-            <a:off x="694944" y="868680"/>
-            <a:ext cx="724205" cy="329184"/>
-          </a:xfrm>
-          <a:prstGeom prst="rect">
-            <a:avLst/>
-          </a:prstGeom>
-        </p:spPr>
-      </p:pic>
-      <p:sp>
-        <p:nvSpPr>
-          <p:cNvPr id="5" name="Shape 2"/>
-          <p:cNvSpPr/>
-          <p:nvPr/>
-        </p:nvSpPr>
-        <p:spPr>
-          <a:xfrm>
-            <a:off x="1538021" y="850392"/>
-            <a:ext cx="365760" cy="365760"/>
-          </a:xfrm>
-          <a:prstGeom prst="roundRect">
-            <a:avLst>
-              <a:gd name="adj" fmla="val 10000"/>
-            </a:avLst>
-          </a:prstGeom>
-          <a:solidFill>
-            <a:srgbClr val="FFFFFF">
-              <a:alpha val="92000"/>
-            </a:srgbClr>
-          </a:solidFill>
-          <a:ln w="6350">
-            <a:solidFill>
-              <a:srgbClr val="D0D7DE"/>
-            </a:solidFill>
-            <a:prstDash val="solid"/>
-          </a:ln>
-        </p:spPr>
-        <p:txBody>
-          <a:bodyPr/>
-          <a:lstStyle/>
-          <a:p>
-            <a:endParaRPr lang="en-US"/>
-          </a:p>
-        </p:txBody>
-      </p:sp>
-      <p:pic>
-        <p:nvPicPr>
-          <p:cNvPr id="6" name="Image 1" descr="/home/jordanbean/source/repos/github-copilot-for-data-professionals/deck/assets/icons/github-copilot.png"/>
-          <p:cNvPicPr>
-            <a:picLocks noChangeAspect="1"/>
-          </p:cNvPicPr>
-          <p:nvPr/>
-        </p:nvPicPr>
-        <p:blipFill>
-          <a:blip r:embed="rId4"/>
-          <a:stretch>
-            <a:fillRect/>
-          </a:stretch>
-        </p:blipFill>
-        <p:spPr>
-          <a:xfrm>
-            <a:off x="1556309" y="868680"/>
-            <a:ext cx="329184" cy="329184"/>
-          </a:xfrm>
-          <a:prstGeom prst="rect">
-            <a:avLst/>
-          </a:prstGeom>
-        </p:spPr>
-      </p:pic>
-      <p:sp>
-        <p:nvSpPr>
-          <p:cNvPr id="7" name="Shape 3"/>
-          <p:cNvSpPr/>
-          <p:nvPr/>
-        </p:nvSpPr>
-        <p:spPr>
-          <a:xfrm>
-            <a:off x="2004365" y="850392"/>
-            <a:ext cx="365760" cy="365760"/>
-          </a:xfrm>
-          <a:prstGeom prst="roundRect">
-            <a:avLst>
-              <a:gd name="adj" fmla="val 10000"/>
-            </a:avLst>
-          </a:prstGeom>
-          <a:solidFill>
-            <a:srgbClr val="FFFFFF">
-              <a:alpha val="92000"/>
-            </a:srgbClr>
-          </a:solidFill>
-          <a:ln w="6350">
-            <a:solidFill>
-              <a:srgbClr val="D0D7DE"/>
-            </a:solidFill>
-            <a:prstDash val="solid"/>
-          </a:ln>
-        </p:spPr>
-        <p:txBody>
-          <a:bodyPr/>
-          <a:lstStyle/>
-          <a:p>
-            <a:endParaRPr lang="en-US"/>
-          </a:p>
-        </p:txBody>
-      </p:sp>
-      <p:pic>
-        <p:nvPicPr>
-          <p:cNvPr id="8" name="Image 2" descr="/home/jordanbean/source/repos/github-copilot-for-data-professionals/deck/assets/icons/microsoft-fabric.png"/>
-          <p:cNvPicPr>
-            <a:picLocks noChangeAspect="1"/>
-          </p:cNvPicPr>
-          <p:nvPr/>
-        </p:nvPicPr>
-        <p:blipFill>
-          <a:blip r:embed="rId5"/>
-          <a:stretch>
-            <a:fillRect/>
-          </a:stretch>
-        </p:blipFill>
-        <p:spPr>
-          <a:xfrm>
-            <a:off x="2022653" y="868680"/>
-            <a:ext cx="329184" cy="329184"/>
-          </a:xfrm>
-          <a:prstGeom prst="rect">
-            <a:avLst/>
-          </a:prstGeom>
-        </p:spPr>
-      </p:pic>
-      <p:pic>
-        <p:nvPicPr>
-          <p:cNvPr id="9" name="Image 3" descr="/home/jordanbean/source/repos/github-copilot-for-data-professionals/deck/assets/fabric-architecture.png"/>
-          <p:cNvPicPr>
-            <a:picLocks noChangeAspect="1"/>
-          </p:cNvPicPr>
-          <p:nvPr/>
-        </p:nvPicPr>
-        <p:blipFill>
-          <a:blip r:embed="rId6"/>
-          <a:stretch>
-            <a:fillRect/>
-          </a:stretch>
-        </p:blipFill>
-        <p:spPr>
-          <a:xfrm>
             <a:off x="685800" y="1097280"/>
             <a:ext cx="11064240" cy="4480560"/>
           </a:xfrm>
@@ -7580,51 +6769,13 @@
       </p:sp>
       <p:sp>
         <p:nvSpPr>
-          <p:cNvPr id="12" name="Text 6"/>
-          <p:cNvSpPr/>
-          <p:nvPr/>
-        </p:nvSpPr>
-        <p:spPr>
-          <a:xfrm>
-            <a:off x="960120" y="5797296"/>
-            <a:ext cx="10652760" cy="384048"/>
-          </a:xfrm>
-          <a:prstGeom prst="rect">
-            <a:avLst/>
-          </a:prstGeom>
-          <a:noFill/>
-          <a:ln/>
-        </p:spPr>
-        <p:txBody>
-          <a:bodyPr wrap="square" lIns="0" tIns="12700" rIns="0" bIns="12700" rtlCol="0" anchor="ctr">
-            <a:normAutofit/>
-          </a:bodyPr>
-          <a:lstStyle/>
-          <a:p>
-            <a:pPr marL="0" indent="0">
-              <a:buNone/>
-            </a:pPr>
-            <a:r>
-              <a:rPr lang="en-US" sz="1200" b="1" dirty="0">
-                <a:solidFill>
-                  <a:srgbClr val="000041"/>
-                </a:solidFill>
-              </a:rPr>
-              <a:t>What this enables</a:t>
-            </a:r>
-            <a:endParaRPr lang="en-US" sz="1200" dirty="0"/>
-          </a:p>
-        </p:txBody>
-      </p:sp>
-      <p:sp>
-        <p:nvSpPr>
           <p:cNvPr id="13" name="Text 7"/>
           <p:cNvSpPr/>
           <p:nvPr/>
         </p:nvSpPr>
         <p:spPr>
           <a:xfrm>
-            <a:off x="960120" y="6181344"/>
+            <a:off x="955548" y="5870448"/>
             <a:ext cx="10652760" cy="219456"/>
           </a:xfrm>
           <a:prstGeom prst="rect">
@@ -8031,7 +7182,7 @@
         </p:spPr>
         <p:txBody>
           <a:bodyPr wrap="square" lIns="254" tIns="12700" rIns="254" bIns="12700" rtlCol="0" anchor="ctr">
-            <a:normAutofit/>
+            <a:normAutofit lnSpcReduction="10000"/>
           </a:bodyPr>
           <a:lstStyle/>
           <a:p>
@@ -8411,7 +7562,7 @@
         </p:spPr>
         <p:txBody>
           <a:bodyPr wrap="square" lIns="0" tIns="12700" rIns="0" bIns="12700" rtlCol="0" anchor="ctr">
-            <a:normAutofit/>
+            <a:normAutofit fontScale="92500"/>
           </a:bodyPr>
           <a:lstStyle/>
           <a:p>
@@ -8462,7 +7613,7 @@
                   <a:srgbClr val="75757A"/>
                 </a:solidFill>
               </a:rPr>
-              <a:t>Live example: synthetic purchase orders + shipments + inventory</a:t>
+              <a:t>Live example: purchase orders + shipments + inventory</a:t>
             </a:r>
             <a:endParaRPr lang="en-US" sz="1050" dirty="0"/>
           </a:p>
@@ -8845,7 +7996,7 @@
         </p:spPr>
         <p:txBody>
           <a:bodyPr wrap="square" lIns="254" tIns="12700" rIns="254" bIns="12700" rtlCol="0" anchor="ctr">
-            <a:normAutofit/>
+            <a:normAutofit lnSpcReduction="10000"/>
           </a:bodyPr>
           <a:lstStyle/>
           <a:p>
@@ -9659,7 +8810,7 @@
         </p:spPr>
         <p:txBody>
           <a:bodyPr wrap="square" lIns="254" tIns="12700" rIns="254" bIns="12700" rtlCol="0" anchor="ctr">
-            <a:normAutofit/>
+            <a:normAutofit lnSpcReduction="10000"/>
           </a:bodyPr>
           <a:lstStyle/>
           <a:p>
@@ -10039,7 +9190,7 @@
         </p:spPr>
         <p:txBody>
           <a:bodyPr wrap="square" lIns="0" tIns="12700" rIns="0" bIns="12700" rtlCol="0" anchor="ctr">
-            <a:normAutofit/>
+            <a:normAutofit fontScale="92500"/>
           </a:bodyPr>
           <a:lstStyle/>
           <a:p>
@@ -10473,7 +9624,7 @@
         </p:spPr>
         <p:txBody>
           <a:bodyPr wrap="square" lIns="254" tIns="12700" rIns="254" bIns="12700" rtlCol="0" anchor="ctr">
-            <a:normAutofit/>
+            <a:normAutofit lnSpcReduction="10000"/>
           </a:bodyPr>
           <a:lstStyle/>
           <a:p>
@@ -11287,7 +10438,7 @@
         </p:spPr>
         <p:txBody>
           <a:bodyPr wrap="square" lIns="254" tIns="12700" rIns="254" bIns="12700" rtlCol="0" anchor="ctr">
-            <a:normAutofit/>
+            <a:normAutofit lnSpcReduction="10000"/>
           </a:bodyPr>
           <a:lstStyle/>
           <a:p>

</xml_diff>

<commit_message>
Remove Oxford commas from deck text and generator scripts
- Strip serial/Oxford commas from slide text, generated architecture
  and SQL-analytics diagram images, and generator source in
  build_deck.js so future rebuilds stay consistent

Co-authored-by: Copilot <223556219+Copilot@users.noreply.github.com>
</commit_message>
<xml_diff>
--- a/deck/github-copilot-for-data-professionals.pptx
+++ b/deck/github-copilot-for-data-professionals.pptx
@@ -2301,8 +2301,8 @@
         </p:nvSpPr>
         <p:spPr>
           <a:xfrm>
-            <a:off x="749808" y="5230368"/>
-            <a:ext cx="3200400" cy="320040"/>
+            <a:off x="749807" y="5230368"/>
+            <a:ext cx="5468429" cy="320040"/>
           </a:xfrm>
           <a:prstGeom prst="rect">
             <a:avLst/>
@@ -2312,7 +2312,7 @@
         </p:spPr>
         <p:txBody>
           <a:bodyPr wrap="square" lIns="0" tIns="12700" rIns="0" bIns="12700" rtlCol="0" anchor="ctr">
-            <a:normAutofit fontScale="85000" lnSpcReduction="20000"/>
+            <a:noAutofit/>
           </a:bodyPr>
           <a:lstStyle/>
           <a:p>
@@ -2320,7 +2320,7 @@
               <a:buNone/>
             </a:pPr>
             <a:r>
-              <a:rPr lang="en-US" sz="1400" dirty="0">
+              <a:rPr lang="en-US" sz="2000" dirty="0">
                 <a:solidFill>
                   <a:srgbClr val="FFFFFF"/>
                 </a:solidFill>
@@ -2333,14 +2333,14 @@
               <a:buNone/>
             </a:pPr>
             <a:r>
-              <a:rPr lang="en-US" sz="1400" dirty="0">
+              <a:rPr lang="en-US" sz="2000" dirty="0">
                 <a:solidFill>
                   <a:srgbClr val="FFFFFF"/>
                 </a:solidFill>
               </a:rPr>
               <a:t>Principal Cloud &amp; AI Apps Solution Engineer</a:t>
             </a:r>
-            <a:endParaRPr lang="en-US" sz="1400" dirty="0"/>
+            <a:endParaRPr lang="en-US" sz="2000" dirty="0"/>
           </a:p>
         </p:txBody>
       </p:sp>
@@ -2426,7 +2426,7 @@
         </p:nvSpPr>
         <p:spPr>
           <a:xfrm>
-            <a:off x="9674352" y="301752"/>
+            <a:off x="10442448" y="493776"/>
             <a:ext cx="329184" cy="329184"/>
           </a:xfrm>
           <a:prstGeom prst="roundRect">
@@ -2470,7 +2470,7 @@
         </p:blipFill>
         <p:spPr>
           <a:xfrm>
-            <a:off x="9692640" y="320040"/>
+            <a:off x="10460736" y="512064"/>
             <a:ext cx="292608" cy="292608"/>
           </a:xfrm>
           <a:prstGeom prst="rect">
@@ -2486,7 +2486,7 @@
         </p:nvSpPr>
         <p:spPr>
           <a:xfrm>
-            <a:off x="10058400" y="301752"/>
+            <a:off x="10826496" y="493776"/>
             <a:ext cx="329184" cy="329184"/>
           </a:xfrm>
           <a:prstGeom prst="roundRect">
@@ -2530,7 +2530,7 @@
         </p:blipFill>
         <p:spPr>
           <a:xfrm>
-            <a:off x="10076688" y="320040"/>
+            <a:off x="10844784" y="512064"/>
             <a:ext cx="292608" cy="292608"/>
           </a:xfrm>
           <a:prstGeom prst="rect">
@@ -2546,7 +2546,7 @@
         </p:nvSpPr>
         <p:spPr>
           <a:xfrm>
-            <a:off x="10442448" y="301752"/>
+            <a:off x="11210544" y="493776"/>
             <a:ext cx="329184" cy="329184"/>
           </a:xfrm>
           <a:prstGeom prst="roundRect">
@@ -2590,7 +2590,7 @@
         </p:blipFill>
         <p:spPr>
           <a:xfrm>
-            <a:off x="10460736" y="320040"/>
+            <a:off x="11228832" y="512064"/>
             <a:ext cx="292608" cy="292608"/>
           </a:xfrm>
           <a:prstGeom prst="rect">
@@ -2734,7 +2734,7 @@
                   <a:srgbClr val="000000"/>
                 </a:solidFill>
               </a:rPr>
-              <a:t>Create supply-chain risk features and evaluate a baseline model from orders, shipments, and inventory.</a:t>
+              <a:t>Create supply-chain risk features and evaluate a baseline model from orders, shipments and inventory.</a:t>
             </a:r>
             <a:endParaRPr lang="en-US" sz="1350" dirty="0"/>
           </a:p>
@@ -2876,7 +2876,7 @@
                   <a:srgbClr val="000000"/>
                 </a:solidFill>
               </a:rPr>
-              <a:t>Suggest additional features, check leakage risk, and explain likely drivers in plain language.</a:t>
+              <a:t>Suggest additional features, check leakage risk and explain likely drivers in plain language.</a:t>
             </a:r>
             <a:endParaRPr lang="en-US" sz="1300" dirty="0"/>
           </a:p>
@@ -3240,7 +3240,7 @@
         </p:nvSpPr>
         <p:spPr>
           <a:xfrm>
-            <a:off x="10222992" y="320040"/>
+            <a:off x="10954512" y="534924"/>
             <a:ext cx="338328" cy="338328"/>
           </a:xfrm>
           <a:prstGeom prst="roundRect">
@@ -3284,7 +3284,7 @@
         </p:blipFill>
         <p:spPr>
           <a:xfrm>
-            <a:off x="10241280" y="338328"/>
+            <a:off x="10972800" y="553212"/>
             <a:ext cx="301752" cy="301752"/>
           </a:xfrm>
           <a:prstGeom prst="rect">
@@ -3300,7 +3300,7 @@
         </p:nvSpPr>
         <p:spPr>
           <a:xfrm>
-            <a:off x="10616184" y="320040"/>
+            <a:off x="11347704" y="534924"/>
             <a:ext cx="338328" cy="338328"/>
           </a:xfrm>
           <a:prstGeom prst="roundRect">
@@ -3344,7 +3344,7 @@
         </p:blipFill>
         <p:spPr>
           <a:xfrm>
-            <a:off x="10634472" y="338328"/>
+            <a:off x="11365992" y="553212"/>
             <a:ext cx="301752" cy="301752"/>
           </a:xfrm>
           <a:prstGeom prst="rect">
@@ -3488,7 +3488,7 @@
                   <a:srgbClr val="000000"/>
                 </a:solidFill>
               </a:rPr>
-              <a:t>Dataset shape, schema, platform (Fabric), and business goal.</a:t>
+              <a:t>Dataset shape, schema, platform (Fabric) and business goal.</a:t>
             </a:r>
             <a:endParaRPr lang="en-US" sz="1500" dirty="0"/>
           </a:p>
@@ -3772,7 +3772,7 @@
                   <a:srgbClr val="000000"/>
                 </a:solidFill>
               </a:rPr>
-              <a:t>Performance limits, naming standards, privacy requirements, and accepted libraries.</a:t>
+              <a:t>Performance limits, naming standards, privacy requirements and accepted libraries.</a:t>
             </a:r>
             <a:endParaRPr lang="en-US" sz="1500" dirty="0"/>
           </a:p>
@@ -3914,7 +3914,7 @@
                   <a:srgbClr val="000000"/>
                 </a:solidFill>
               </a:rPr>
-              <a:t>Ask Copilot to add tests, edge cases, assumptions, and failure handling.</a:t>
+              <a:t>Ask Copilot to add tests, edge cases, assumptions and failure handling.</a:t>
             </a:r>
             <a:endParaRPr lang="en-US" sz="1500" dirty="0"/>
           </a:p>
@@ -4026,7 +4026,7 @@
         </p:nvSpPr>
         <p:spPr>
           <a:xfrm>
-            <a:off x="9948672" y="310896"/>
+            <a:off x="10826496" y="475488"/>
             <a:ext cx="329184" cy="329184"/>
           </a:xfrm>
           <a:prstGeom prst="roundRect">
@@ -4070,7 +4070,7 @@
         </p:blipFill>
         <p:spPr>
           <a:xfrm>
-            <a:off x="9966960" y="329184"/>
+            <a:off x="10844784" y="493776"/>
             <a:ext cx="292608" cy="292608"/>
           </a:xfrm>
           <a:prstGeom prst="rect">
@@ -4086,7 +4086,7 @@
         </p:nvSpPr>
         <p:spPr>
           <a:xfrm>
-            <a:off x="10332720" y="310896"/>
+            <a:off x="11210544" y="475488"/>
             <a:ext cx="329184" cy="329184"/>
           </a:xfrm>
           <a:prstGeom prst="roundRect">
@@ -4130,7 +4130,7 @@
         </p:blipFill>
         <p:spPr>
           <a:xfrm>
-            <a:off x="10351008" y="329184"/>
+            <a:off x="11228832" y="493776"/>
             <a:ext cx="292608" cy="292608"/>
           </a:xfrm>
           <a:prstGeom prst="rect">
@@ -4416,7 +4416,7 @@
                   <a:srgbClr val="000000"/>
                 </a:solidFill>
               </a:rPr>
-              <a:t>Defect escape rate, test coverage on generated helpers, and review findings.</a:t>
+              <a:t>Defect escape rate, test coverage on generated helpers and review findings.</a:t>
             </a:r>
             <a:endParaRPr lang="en-US" sz="1250" dirty="0"/>
           </a:p>
@@ -4851,7 +4851,7 @@
                 <a:ea typeface="Segoe UI Semibold" pitchFamily="34" charset="-122"/>
                 <a:cs typeface="Segoe UI Semibold" pitchFamily="34" charset="-120"/>
               </a:rPr>
-              <a:t>Why Copilot for data teams</a:t>
+              <a:t>Why GitHub Copilot for data teams</a:t>
             </a:r>
             <a:endParaRPr lang="en-US" sz="3500" dirty="0"/>
           </a:p>
@@ -5113,7 +5113,7 @@
                   <a:srgbClr val="000000"/>
                 </a:solidFill>
               </a:rPr>
-              <a:t>Schema checks, joins, validation rules, Spark transforms, SQL variants, and notebook cleanup consume significant engineering time.</a:t>
+              <a:t>Schema checks, joins, validation rules, Spark transforms, SQL variants and notebook cleanup consume significant engineering time.</a:t>
             </a:r>
             <a:endParaRPr lang="en-US" sz="1250" dirty="0"/>
           </a:p>
@@ -5255,7 +5255,7 @@
                   <a:srgbClr val="000000"/>
                 </a:solidFill>
               </a:rPr>
-              <a:t>Data engineers move between Python, PySpark, SQL, and platform-specific patterns in the same feature or incident.</a:t>
+              <a:t>Data engineers move between Python, PySpark, SQL and platform-specific patterns in the same feature or incident.</a:t>
             </a:r>
             <a:endParaRPr lang="en-US" sz="1250" dirty="0"/>
           </a:p>
@@ -5397,7 +5397,7 @@
                   <a:srgbClr val="000000"/>
                 </a:solidFill>
               </a:rPr>
-              <a:t>Faster iteration is valuable only when tests, data contracts, and governance checks remain intact.</a:t>
+              <a:t>Faster iteration is valuable only when tests, data contracts and governance checks remain intact.</a:t>
             </a:r>
             <a:endParaRPr lang="en-US" sz="1250" dirty="0"/>
           </a:p>
@@ -5539,7 +5539,7 @@
                   <a:srgbClr val="000000"/>
                 </a:solidFill>
               </a:rPr>
-              <a:t>Draft faster, refine with constraints, and validate with guardrails.</a:t>
+              <a:t>Draft faster, refine with constraints and validate with guardrails.</a:t>
             </a:r>
             <a:endParaRPr lang="en-US" sz="1300" dirty="0"/>
           </a:p>
@@ -5598,7 +5598,7 @@
         </p:spPr>
         <p:txBody>
           <a:bodyPr wrap="square" lIns="254" tIns="12700" rIns="254" bIns="12700" rtlCol="0" anchor="ctr">
-            <a:normAutofit/>
+            <a:normAutofit fontScale="92500" lnSpcReduction="10000"/>
           </a:bodyPr>
           <a:lstStyle/>
           <a:p>
@@ -5611,7 +5611,30 @@
                   <a:srgbClr val="000041"/>
                 </a:solidFill>
               </a:rPr>
-              <a:t>Copilot is most useful for accelerating the middle of data work: drafting, explaining, and refactoring code. Data professionals still own data meaning, reliability, and production readiness.</a:t>
+              <a:t>Copilot is most useful for accelerating the middle of data work: drafting, explaining and refactoring code. </a:t>
+            </a:r>
+          </a:p>
+          <a:p>
+            <a:pPr marL="0" indent="0">
+              <a:buNone/>
+            </a:pPr>
+            <a:endParaRPr lang="en-US" sz="2000" b="1" dirty="0">
+              <a:solidFill>
+                <a:srgbClr val="000041"/>
+              </a:solidFill>
+            </a:endParaRPr>
+          </a:p>
+          <a:p>
+            <a:pPr marL="0" indent="0">
+              <a:buNone/>
+            </a:pPr>
+            <a:r>
+              <a:rPr lang="en-US" sz="2000" b="1" dirty="0">
+                <a:solidFill>
+                  <a:srgbClr val="000041"/>
+                </a:solidFill>
+              </a:rPr>
+              <a:t>Data professionals still own data meaning, reliability and production readiness.</a:t>
             </a:r>
             <a:endParaRPr lang="en-US" sz="2000" dirty="0"/>
           </a:p>
@@ -5967,7 +5990,7 @@
                   <a:srgbClr val="000041"/>
                 </a:solidFill>
               </a:rPr>
-              <a:t>Profile orders, shipments, and inventory</a:t>
+              <a:t>Profile orders, shipments and inventory</a:t>
             </a:r>
             <a:endParaRPr lang="en-US" sz="1100" dirty="0"/>
           </a:p>
@@ -6887,7 +6910,7 @@
         </p:nvSpPr>
         <p:spPr>
           <a:xfrm>
-            <a:off x="9674352" y="301752"/>
+            <a:off x="10607040" y="493776"/>
             <a:ext cx="329184" cy="329184"/>
           </a:xfrm>
           <a:prstGeom prst="roundRect">
@@ -6931,7 +6954,7 @@
         </p:blipFill>
         <p:spPr>
           <a:xfrm>
-            <a:off x="9692640" y="320040"/>
+            <a:off x="10625328" y="512064"/>
             <a:ext cx="292608" cy="292608"/>
           </a:xfrm>
           <a:prstGeom prst="rect">
@@ -6947,7 +6970,7 @@
         </p:nvSpPr>
         <p:spPr>
           <a:xfrm>
-            <a:off x="10058400" y="301752"/>
+            <a:off x="10991088" y="493776"/>
             <a:ext cx="329184" cy="329184"/>
           </a:xfrm>
           <a:prstGeom prst="roundRect">
@@ -6991,7 +7014,7 @@
         </p:blipFill>
         <p:spPr>
           <a:xfrm>
-            <a:off x="10076688" y="320040"/>
+            <a:off x="11009376" y="512064"/>
             <a:ext cx="292608" cy="292608"/>
           </a:xfrm>
           <a:prstGeom prst="rect">
@@ -7007,7 +7030,7 @@
         </p:nvSpPr>
         <p:spPr>
           <a:xfrm>
-            <a:off x="10442448" y="301752"/>
+            <a:off x="11375136" y="493776"/>
             <a:ext cx="329184" cy="329184"/>
           </a:xfrm>
           <a:prstGeom prst="roundRect">
@@ -7051,7 +7074,7 @@
         </p:blipFill>
         <p:spPr>
           <a:xfrm>
-            <a:off x="10460736" y="320040"/>
+            <a:off x="11393424" y="512064"/>
             <a:ext cx="292608" cy="292608"/>
           </a:xfrm>
           <a:prstGeom prst="rect">
@@ -7195,7 +7218,7 @@
                   <a:srgbClr val="000000"/>
                 </a:solidFill>
               </a:rPr>
-              <a:t>Create realistic purchase orders, shipments, and inventory snapshots with normal behavior plus controlled anomalies.</a:t>
+              <a:t>Create realistic purchase orders, shipments and inventory snapshots with normal behavior plus controlled anomalies.</a:t>
             </a:r>
             <a:endParaRPr lang="en-US" sz="1350" dirty="0"/>
           </a:p>
@@ -7337,7 +7360,7 @@
                   <a:srgbClr val="000000"/>
                 </a:solidFill>
               </a:rPr>
-              <a:t>Draft generator code, then add edge cases such as missing plants, blank carriers, negative costs, and low inventory.</a:t>
+              <a:t>Draft generator code, then add edge cases such as missing plants, blank carriers, negative costs and low inventory.</a:t>
             </a:r>
             <a:endParaRPr lang="en-US" sz="1300" dirty="0"/>
           </a:p>
@@ -7701,7 +7724,7 @@
         </p:nvSpPr>
         <p:spPr>
           <a:xfrm>
-            <a:off x="9674352" y="301752"/>
+            <a:off x="10460736" y="493776"/>
             <a:ext cx="329184" cy="329184"/>
           </a:xfrm>
           <a:prstGeom prst="roundRect">
@@ -7745,7 +7768,7 @@
         </p:blipFill>
         <p:spPr>
           <a:xfrm>
-            <a:off x="9692640" y="320040"/>
+            <a:off x="10479024" y="512064"/>
             <a:ext cx="292608" cy="292608"/>
           </a:xfrm>
           <a:prstGeom prst="rect">
@@ -7761,7 +7784,7 @@
         </p:nvSpPr>
         <p:spPr>
           <a:xfrm>
-            <a:off x="10058400" y="301752"/>
+            <a:off x="10844784" y="493776"/>
             <a:ext cx="329184" cy="329184"/>
           </a:xfrm>
           <a:prstGeom prst="roundRect">
@@ -7805,7 +7828,7 @@
         </p:blipFill>
         <p:spPr>
           <a:xfrm>
-            <a:off x="10076688" y="320040"/>
+            <a:off x="10863072" y="512064"/>
             <a:ext cx="292608" cy="292608"/>
           </a:xfrm>
           <a:prstGeom prst="rect">
@@ -7821,7 +7844,7 @@
         </p:nvSpPr>
         <p:spPr>
           <a:xfrm>
-            <a:off x="10442448" y="301752"/>
+            <a:off x="11228832" y="493776"/>
             <a:ext cx="329184" cy="329184"/>
           </a:xfrm>
           <a:prstGeom prst="roundRect">
@@ -7865,7 +7888,7 @@
         </p:blipFill>
         <p:spPr>
           <a:xfrm>
-            <a:off x="10460736" y="320040"/>
+            <a:off x="11247120" y="512064"/>
             <a:ext cx="292608" cy="292608"/>
           </a:xfrm>
           <a:prstGeom prst="rect">
@@ -8009,7 +8032,7 @@
                   <a:srgbClr val="000000"/>
                 </a:solidFill>
               </a:rPr>
-              <a:t>Understand order, shipment, and inventory quality before building downstream transformations.</a:t>
+              <a:t>Understand order, shipment and inventory quality before building downstream transformations.</a:t>
             </a:r>
             <a:endParaRPr lang="en-US" sz="1350" dirty="0"/>
           </a:p>
@@ -8151,7 +8174,7 @@
                   <a:srgbClr val="000000"/>
                 </a:solidFill>
               </a:rPr>
-              <a:t>Generate reusable profiling helpers for missing plants, blank carriers, value ranges, and sample records.</a:t>
+              <a:t>Generate reusable profiling helpers for missing plants, blank carriers, value ranges and sample records.</a:t>
             </a:r>
             <a:endParaRPr lang="en-US" sz="1300" dirty="0"/>
           </a:p>
@@ -8515,7 +8538,7 @@
         </p:nvSpPr>
         <p:spPr>
           <a:xfrm>
-            <a:off x="9674352" y="301752"/>
+            <a:off x="10625328" y="479708"/>
             <a:ext cx="329184" cy="329184"/>
           </a:xfrm>
           <a:prstGeom prst="roundRect">
@@ -8559,7 +8582,7 @@
         </p:blipFill>
         <p:spPr>
           <a:xfrm>
-            <a:off x="9692640" y="320040"/>
+            <a:off x="10643616" y="497996"/>
             <a:ext cx="292608" cy="292608"/>
           </a:xfrm>
           <a:prstGeom prst="rect">
@@ -8575,7 +8598,7 @@
         </p:nvSpPr>
         <p:spPr>
           <a:xfrm>
-            <a:off x="10058400" y="301752"/>
+            <a:off x="11009376" y="479708"/>
             <a:ext cx="329184" cy="329184"/>
           </a:xfrm>
           <a:prstGeom prst="roundRect">
@@ -8619,7 +8642,7 @@
         </p:blipFill>
         <p:spPr>
           <a:xfrm>
-            <a:off x="10076688" y="320040"/>
+            <a:off x="11027664" y="497996"/>
             <a:ext cx="292608" cy="292608"/>
           </a:xfrm>
           <a:prstGeom prst="rect">
@@ -8635,7 +8658,7 @@
         </p:nvSpPr>
         <p:spPr>
           <a:xfrm>
-            <a:off x="10442448" y="301752"/>
+            <a:off x="11393424" y="479708"/>
             <a:ext cx="329184" cy="329184"/>
           </a:xfrm>
           <a:prstGeom prst="roundRect">
@@ -8679,7 +8702,7 @@
         </p:blipFill>
         <p:spPr>
           <a:xfrm>
-            <a:off x="10460736" y="320040"/>
+            <a:off x="11411712" y="497996"/>
             <a:ext cx="292608" cy="292608"/>
           </a:xfrm>
           <a:prstGeom prst="rect">
@@ -8965,7 +8988,7 @@
                   <a:srgbClr val="000000"/>
                 </a:solidFill>
               </a:rPr>
-              <a:t>Draft validation rules for required fields, positive quantities, plausible dates, and non-negative costs.</a:t>
+              <a:t>Draft validation rules for required fields, positive quantities, plausible dates and non-negative costs.</a:t>
             </a:r>
             <a:endParaRPr lang="en-US" sz="1300" dirty="0"/>
           </a:p>
@@ -9241,7 +9264,7 @@
                   <a:srgbClr val="75757A"/>
                 </a:solidFill>
               </a:rPr>
-              <a:t>Live example: PO, shipment, and inventory quarantine checks</a:t>
+              <a:t>Live example: PO, shipment and inventory quarantine checks</a:t>
             </a:r>
             <a:endParaRPr lang="en-US" sz="1050" dirty="0"/>
           </a:p>
@@ -9329,7 +9352,7 @@
         </p:nvSpPr>
         <p:spPr>
           <a:xfrm>
-            <a:off x="9674352" y="301752"/>
+            <a:off x="10607040" y="493776"/>
             <a:ext cx="329184" cy="329184"/>
           </a:xfrm>
           <a:prstGeom prst="roundRect">
@@ -9373,7 +9396,7 @@
         </p:blipFill>
         <p:spPr>
           <a:xfrm>
-            <a:off x="9692640" y="320040"/>
+            <a:off x="10625328" y="512064"/>
             <a:ext cx="292608" cy="292608"/>
           </a:xfrm>
           <a:prstGeom prst="rect">
@@ -9389,7 +9412,7 @@
         </p:nvSpPr>
         <p:spPr>
           <a:xfrm>
-            <a:off x="10058400" y="301752"/>
+            <a:off x="10991088" y="493776"/>
             <a:ext cx="329184" cy="329184"/>
           </a:xfrm>
           <a:prstGeom prst="roundRect">
@@ -9433,7 +9456,7 @@
         </p:blipFill>
         <p:spPr>
           <a:xfrm>
-            <a:off x="10076688" y="320040"/>
+            <a:off x="11009376" y="512064"/>
             <a:ext cx="292608" cy="292608"/>
           </a:xfrm>
           <a:prstGeom prst="rect">
@@ -9449,7 +9472,7 @@
         </p:nvSpPr>
         <p:spPr>
           <a:xfrm>
-            <a:off x="10442448" y="301752"/>
+            <a:off x="11375136" y="493776"/>
             <a:ext cx="329184" cy="329184"/>
           </a:xfrm>
           <a:prstGeom prst="roundRect">
@@ -9493,7 +9516,7 @@
         </p:blipFill>
         <p:spPr>
           <a:xfrm>
-            <a:off x="10460736" y="320040"/>
+            <a:off x="11393424" y="512064"/>
             <a:ext cx="292608" cy="292608"/>
           </a:xfrm>
           <a:prstGeom prst="rect">
@@ -10143,7 +10166,7 @@
         </p:nvSpPr>
         <p:spPr>
           <a:xfrm>
-            <a:off x="9674352" y="301752"/>
+            <a:off x="10607040" y="470916"/>
             <a:ext cx="329184" cy="329184"/>
           </a:xfrm>
           <a:prstGeom prst="roundRect">
@@ -10187,7 +10210,7 @@
         </p:blipFill>
         <p:spPr>
           <a:xfrm>
-            <a:off x="9692640" y="320040"/>
+            <a:off x="10625328" y="489204"/>
             <a:ext cx="292608" cy="292608"/>
           </a:xfrm>
           <a:prstGeom prst="rect">
@@ -10203,7 +10226,7 @@
         </p:nvSpPr>
         <p:spPr>
           <a:xfrm>
-            <a:off x="10058400" y="301752"/>
+            <a:off x="10991088" y="470916"/>
             <a:ext cx="329184" cy="329184"/>
           </a:xfrm>
           <a:prstGeom prst="roundRect">
@@ -10247,7 +10270,7 @@
         </p:blipFill>
         <p:spPr>
           <a:xfrm>
-            <a:off x="10076688" y="320040"/>
+            <a:off x="11009376" y="489204"/>
             <a:ext cx="292608" cy="292608"/>
           </a:xfrm>
           <a:prstGeom prst="rect">
@@ -10263,7 +10286,7 @@
         </p:nvSpPr>
         <p:spPr>
           <a:xfrm>
-            <a:off x="10442448" y="301752"/>
+            <a:off x="11375136" y="470916"/>
             <a:ext cx="329184" cy="329184"/>
           </a:xfrm>
           <a:prstGeom prst="roundRect">
@@ -10307,7 +10330,7 @@
         </p:blipFill>
         <p:spPr>
           <a:xfrm>
-            <a:off x="10460736" y="320040"/>
+            <a:off x="11393424" y="489204"/>
             <a:ext cx="292608" cy="292608"/>
           </a:xfrm>
           <a:prstGeom prst="rect">
@@ -10593,7 +10616,7 @@
                   <a:srgbClr val="000000"/>
                 </a:solidFill>
               </a:rPr>
-              <a:t>Draft the SQL, then explain assumptions in joins, filters, and window logic.</a:t>
+              <a:t>Draft the SQL, then explain assumptions in joins, filters and window logic.</a:t>
             </a:r>
             <a:endParaRPr lang="en-US" sz="1300" dirty="0"/>
           </a:p>
@@ -10735,7 +10758,7 @@
                   <a:srgbClr val="000000"/>
                 </a:solidFill>
               </a:rPr>
-              <a:t>Analysts identify risky suppliers, lanes, and parts faster while keeping logic transparent.</a:t>
+              <a:t>Analysts identify risky suppliers, lanes and parts faster while keeping logic transparent.</a:t>
             </a:r>
             <a:endParaRPr lang="en-US" sz="1250" dirty="0"/>
           </a:p>

</xml_diff>